<commit_message>
Add KCM design format and apply it across tool and documents
Derive the brand palette by pixel-sampling the KCM company brochure
(blue #045292, lime #B6D55E, marker #E3EA61, plus sub colors), and
codify it as a design-format deck and markdown spec: heading style
with English label and marker highlight, lime diagonal footer stripe,
Q-badge chips, rounded cards. Retheme the explanation deck, both
manual editions, and the tool UI accent colors to match, with a
placeholder logo noted for replacement from the official AI data.

Co-Authored-By: Claude Fable 5 <noreply@anthropic.com>
Claude-Session: https://claude.ai/code/session_01YP9GdZdJDnpqd6g2eHojHD
</commit_message>
<xml_diff>
--- a/sekisan/docs/KCM積算ツール_ご説明資料.pptx
+++ b/sekisan/docs/KCM積算ツール_ご説明資料.pptx
@@ -1480,7 +1480,7 @@
     <p:bg>
       <p:bgPr>
         <a:solidFill>
-          <a:srgbClr val="1E2761"/>
+          <a:srgbClr val="FFFFFF"/>
         </a:solidFill>
       </p:bgPr>
     </p:bg>
@@ -1498,16 +1498,64 @@
           <a:chExt cx="0" cy="0"/>
         </a:xfrm>
       </p:grpSpPr>
-      <p:sp>
-        <p:nvSpPr>
-          <p:cNvPr id="2" name="Text 0"/>
-          <p:cNvSpPr txBox="1"/>
-          <p:nvPr/>
-        </p:nvSpPr>
-        <p:spPr>
-          <a:xfrm>
-            <a:off x="822960" y="2148840"/>
-            <a:ext cx="10515600" cy="1005840"/>
+      <p:pic>
+        <p:nvPicPr>
+          <p:cNvPr id="2" name="Image 0" descr="/tmp/claude-0/-home-user-takashima-yuto-site/d68be841-4a50-5410-afb9-fdf52bb655ee/scratchpad/sekisan/kcm_stripe.png">    </p:cNvPr>
+          <p:cNvPicPr>
+            <a:picLocks noChangeAspect="1"/>
+          </p:cNvPicPr>
+          <p:nvPr/>
+        </p:nvPicPr>
+        <p:blipFill>
+          <a:blip r:embed="rId1"/>
+          <a:stretch>
+            <a:fillRect/>
+          </a:stretch>
+        </p:blipFill>
+        <p:spPr>
+          <a:xfrm>
+            <a:off x="0" y="6656832"/>
+            <a:ext cx="12188952" cy="201168"/>
+          </a:xfrm>
+          <a:prstGeom prst="rect">
+            <a:avLst/>
+          </a:prstGeom>
+        </p:spPr>
+      </p:pic>
+      <p:pic>
+        <p:nvPicPr>
+          <p:cNvPr id="3" name="Image 1" descr="/tmp/claude-0/-home-user-takashima-yuto-site/d68be841-4a50-5410-afb9-fdf52bb655ee/scratchpad/sekisan/kcm_logo_placeholder.png">    </p:cNvPr>
+          <p:cNvPicPr>
+            <a:picLocks noChangeAspect="1"/>
+          </p:cNvPicPr>
+          <p:nvPr/>
+        </p:nvPicPr>
+        <p:blipFill>
+          <a:blip r:embed="rId2"/>
+          <a:stretch>
+            <a:fillRect/>
+          </a:stretch>
+        </p:blipFill>
+        <p:spPr>
+          <a:xfrm>
+            <a:off x="502920" y="411480"/>
+            <a:ext cx="960120" cy="403250"/>
+          </a:xfrm>
+          <a:prstGeom prst="rect">
+            <a:avLst/>
+          </a:prstGeom>
+        </p:spPr>
+      </p:pic>
+      <p:sp>
+        <p:nvSpPr>
+          <p:cNvPr id="4" name="Text 0"/>
+          <p:cNvSpPr txBox="1"/>
+          <p:nvPr/>
+        </p:nvSpPr>
+        <p:spPr>
+          <a:xfrm>
+            <a:off x="548640" y="2103120"/>
+            <a:ext cx="10972800" cy="320040"/>
           </a:xfrm>
           <a:prstGeom prst="rect">
             <a:avLst/>
@@ -1523,9 +1571,70 @@
               <a:buNone/>
             </a:pPr>
             <a:r>
-              <a:rPr lang="en-US" sz="5400" b="1" dirty="0">
-                <a:solidFill>
-                  <a:srgbClr val="FFFFFF"/>
+              <a:rPr lang="en-US" sz="1300" b="1" spc="300" kern="0" dirty="0">
+                <a:solidFill>
+                  <a:srgbClr val="045292"/>
+                </a:solidFill>
+                <a:latin typeface="Arial" pitchFamily="34" charset="0"/>
+                <a:ea typeface="Arial" pitchFamily="34" charset="-122"/>
+                <a:cs typeface="Arial" pitchFamily="34" charset="-120"/>
+              </a:rPr>
+              <a:t>SEKISAN SUPPORT TOOL</a:t>
+            </a:r>
+            <a:endParaRPr lang="en-US" sz="1300" dirty="0"/>
+          </a:p>
+        </p:txBody>
+      </p:sp>
+      <p:sp>
+        <p:nvSpPr>
+          <p:cNvPr id="5" name="Shape 1"/>
+          <p:cNvSpPr/>
+          <p:nvPr/>
+        </p:nvSpPr>
+        <p:spPr>
+          <a:xfrm>
+            <a:off x="475488" y="3127248"/>
+            <a:ext cx="5852160" cy="420624"/>
+          </a:xfrm>
+          <a:prstGeom prst="rect">
+            <a:avLst/>
+          </a:prstGeom>
+          <a:solidFill>
+            <a:srgbClr val="E3EA61">
+              <a:alpha val="75000"/>
+            </a:srgbClr>
+          </a:solidFill>
+          <a:ln/>
+        </p:spPr>
+      </p:sp>
+      <p:sp>
+        <p:nvSpPr>
+          <p:cNvPr id="6" name="Text 2"/>
+          <p:cNvSpPr txBox="1"/>
+          <p:nvPr/>
+        </p:nvSpPr>
+        <p:spPr>
+          <a:xfrm>
+            <a:off x="548640" y="2468880"/>
+            <a:ext cx="10515600" cy="960120"/>
+          </a:xfrm>
+          <a:prstGeom prst="rect">
+            <a:avLst/>
+          </a:prstGeom>
+          <a:noFill/>
+          <a:ln/>
+        </p:spPr>
+        <p:txBody>
+          <a:bodyPr wrap="square" lIns="0" tIns="0" rIns="0" bIns="0" rtlCol="0" anchor="ctr"/>
+          <a:lstStyle/>
+          <a:p>
+            <a:pPr indent="0" marL="0">
+              <a:buNone/>
+            </a:pPr>
+            <a:r>
+              <a:rPr lang="en-US" sz="5200" b="1" dirty="0">
+                <a:solidFill>
+                  <a:srgbClr val="1C2430"/>
                 </a:solidFill>
                 <a:latin typeface="Meiryo UI" pitchFamily="34" charset="0"/>
                 <a:ea typeface="Meiryo UI" pitchFamily="34" charset="-122"/>
@@ -1533,19 +1642,19 @@
               </a:rPr>
               <a:t>KCM積算ツール</a:t>
             </a:r>
-            <a:endParaRPr lang="en-US" sz="5400" dirty="0"/>
-          </a:p>
-        </p:txBody>
-      </p:sp>
-      <p:sp>
-        <p:nvSpPr>
-          <p:cNvPr id="3" name="Text 1"/>
-          <p:cNvSpPr txBox="1"/>
-          <p:nvPr/>
-        </p:nvSpPr>
-        <p:spPr>
-          <a:xfrm>
-            <a:off x="841248" y="3246120"/>
+            <a:endParaRPr lang="en-US" sz="5200" dirty="0"/>
+          </a:p>
+        </p:txBody>
+      </p:sp>
+      <p:sp>
+        <p:nvSpPr>
+          <p:cNvPr id="7" name="Text 3"/>
+          <p:cNvSpPr txBox="1"/>
+          <p:nvPr/>
+        </p:nvSpPr>
+        <p:spPr>
+          <a:xfrm>
+            <a:off x="566928" y="3611880"/>
             <a:ext cx="10515600" cy="548640"/>
           </a:xfrm>
           <a:prstGeom prst="rect">
@@ -1562,9 +1671,9 @@
               <a:buNone/>
             </a:pPr>
             <a:r>
-              <a:rPr lang="en-US" sz="2400" dirty="0">
-                <a:solidFill>
-                  <a:srgbClr val="CADCFC"/>
+              <a:rPr lang="en-US" sz="2300" b="1" dirty="0">
+                <a:solidFill>
+                  <a:srgbClr val="045292"/>
                 </a:solidFill>
                 <a:latin typeface="Meiryo UI" pitchFamily="34" charset="0"/>
                 <a:ea typeface="Meiryo UI" pitchFamily="34" charset="-122"/>
@@ -1572,20 +1681,20 @@
               </a:rPr>
               <a:t>積算業務支援システム　ご説明資料</a:t>
             </a:r>
-            <a:endParaRPr lang="en-US" sz="2400" dirty="0"/>
-          </a:p>
-        </p:txBody>
-      </p:sp>
-      <p:sp>
-        <p:nvSpPr>
-          <p:cNvPr id="4" name="Text 2"/>
-          <p:cNvSpPr txBox="1"/>
-          <p:nvPr/>
-        </p:nvSpPr>
-        <p:spPr>
-          <a:xfrm>
-            <a:off x="841248" y="3977640"/>
-            <a:ext cx="9601200" cy="457200"/>
+            <a:endParaRPr lang="en-US" sz="2300" dirty="0"/>
+          </a:p>
+        </p:txBody>
+      </p:sp>
+      <p:sp>
+        <p:nvSpPr>
+          <p:cNvPr id="8" name="Text 4"/>
+          <p:cNvSpPr txBox="1"/>
+          <p:nvPr/>
+        </p:nvSpPr>
+        <p:spPr>
+          <a:xfrm>
+            <a:off x="566928" y="4297680"/>
+            <a:ext cx="9875520" cy="457200"/>
           </a:xfrm>
           <a:prstGeom prst="rect">
             <a:avLst/>
@@ -1603,7 +1712,7 @@
             <a:r>
               <a:rPr lang="en-US" sz="1400" dirty="0">
                 <a:solidFill>
-                  <a:srgbClr val="CADCFC"/>
+                  <a:srgbClr val="5A6472"/>
                 </a:solidFill>
                 <a:latin typeface="Meiryo UI" pitchFamily="34" charset="0"/>
                 <a:ea typeface="Meiryo UI" pitchFamily="34" charset="-122"/>
@@ -1617,13 +1726,13 @@
       </p:sp>
       <p:sp>
         <p:nvSpPr>
-          <p:cNvPr id="5" name="Text 3"/>
-          <p:cNvSpPr txBox="1"/>
-          <p:nvPr/>
-        </p:nvSpPr>
-        <p:spPr>
-          <a:xfrm>
-            <a:off x="841248" y="5669280"/>
+          <p:cNvPr id="9" name="Text 5"/>
+          <p:cNvSpPr txBox="1"/>
+          <p:nvPr/>
+        </p:nvSpPr>
+        <p:spPr>
+          <a:xfrm>
+            <a:off x="566928" y="5623560"/>
             <a:ext cx="7315200" cy="822960"/>
           </a:xfrm>
           <a:prstGeom prst="rect">
@@ -1645,7 +1754,7 @@
             <a:r>
               <a:rPr lang="en-US" sz="1400" dirty="0">
                 <a:solidFill>
-                  <a:srgbClr val="FFFFFF"/>
+                  <a:srgbClr val="1C2430"/>
                 </a:solidFill>
                 <a:latin typeface="Meiryo UI" pitchFamily="34" charset="0"/>
                 <a:ea typeface="Meiryo UI" pitchFamily="34" charset="-122"/>
@@ -1663,7 +1772,7 @@
             <a:r>
               <a:rPr lang="en-US" sz="1400" dirty="0">
                 <a:solidFill>
-                  <a:srgbClr val="CADCFC"/>
+                  <a:srgbClr val="5A6472"/>
                 </a:solidFill>
                 <a:latin typeface="Meiryo UI" pitchFamily="34" charset="0"/>
                 <a:ea typeface="Meiryo UI" pitchFamily="34" charset="-122"/>
@@ -1707,9 +1816,33 @@
           <a:chExt cx="0" cy="0"/>
         </a:xfrm>
       </p:grpSpPr>
-      <p:sp>
-        <p:nvSpPr>
-          <p:cNvPr id="2" name="Text 0"/>
+      <p:pic>
+        <p:nvPicPr>
+          <p:cNvPr id="2" name="Image 0" descr="/tmp/claude-0/-home-user-takashima-yuto-site/d68be841-4a50-5410-afb9-fdf52bb655ee/scratchpad/sekisan/kcm_stripe.png">    </p:cNvPr>
+          <p:cNvPicPr>
+            <a:picLocks noChangeAspect="1"/>
+          </p:cNvPicPr>
+          <p:nvPr/>
+        </p:nvPicPr>
+        <p:blipFill>
+          <a:blip r:embed="rId1"/>
+          <a:stretch>
+            <a:fillRect/>
+          </a:stretch>
+        </p:blipFill>
+        <p:spPr>
+          <a:xfrm>
+            <a:off x="0" y="6656832"/>
+            <a:ext cx="12188952" cy="201168"/>
+          </a:xfrm>
+          <a:prstGeom prst="rect">
+            <a:avLst/>
+          </a:prstGeom>
+        </p:spPr>
+      </p:pic>
+      <p:sp>
+        <p:nvSpPr>
+          <p:cNvPr id="3" name="Text 0"/>
           <p:cNvSpPr txBox="1"/>
           <p:nvPr/>
         </p:nvSpPr>
@@ -1734,7 +1867,7 @@
             <a:r>
               <a:rPr lang="en-US" sz="2800" b="1" dirty="0">
                 <a:solidFill>
-                  <a:srgbClr val="1E2761"/>
+                  <a:srgbClr val="045292"/>
                 </a:solidFill>
                 <a:latin typeface="Meiryo UI" pitchFamily="34" charset="0"/>
                 <a:ea typeface="Meiryo UI" pitchFamily="34" charset="-122"/>
@@ -1748,7 +1881,7 @@
       </p:sp>
       <p:sp>
         <p:nvSpPr>
-          <p:cNvPr id="3" name="Shape 1"/>
+          <p:cNvPr id="4" name="Shape 1"/>
           <p:cNvSpPr/>
           <p:nvPr/>
         </p:nvSpPr>
@@ -1763,14 +1896,14 @@
             </a:avLst>
           </a:prstGeom>
           <a:solidFill>
-            <a:srgbClr val="1E2761"/>
+            <a:srgbClr val="045292"/>
           </a:solidFill>
           <a:ln/>
         </p:spPr>
       </p:sp>
       <p:sp>
         <p:nvSpPr>
-          <p:cNvPr id="4" name="Text 2"/>
+          <p:cNvPr id="5" name="Text 2"/>
           <p:cNvSpPr txBox="1"/>
           <p:nvPr/>
         </p:nvSpPr>
@@ -1809,7 +1942,7 @@
       </p:sp>
       <p:sp>
         <p:nvSpPr>
-          <p:cNvPr id="5" name="Text 3"/>
+          <p:cNvPr id="6" name="Text 3"/>
           <p:cNvSpPr txBox="1"/>
           <p:nvPr/>
         </p:nvSpPr>
@@ -1848,7 +1981,7 @@
       </p:sp>
       <p:sp>
         <p:nvSpPr>
-          <p:cNvPr id="6" name="Shape 4"/>
+          <p:cNvPr id="7" name="Shape 4"/>
           <p:cNvSpPr/>
           <p:nvPr/>
         </p:nvSpPr>
@@ -1863,14 +1996,14 @@
             </a:avLst>
           </a:prstGeom>
           <a:solidFill>
-            <a:srgbClr val="1E2761"/>
+            <a:srgbClr val="045292"/>
           </a:solidFill>
           <a:ln/>
         </p:spPr>
       </p:sp>
       <p:sp>
         <p:nvSpPr>
-          <p:cNvPr id="7" name="Text 5"/>
+          <p:cNvPr id="8" name="Text 5"/>
           <p:cNvSpPr txBox="1"/>
           <p:nvPr/>
         </p:nvSpPr>
@@ -1909,7 +2042,7 @@
       </p:sp>
       <p:sp>
         <p:nvSpPr>
-          <p:cNvPr id="8" name="Text 6"/>
+          <p:cNvPr id="9" name="Text 6"/>
           <p:cNvSpPr txBox="1"/>
           <p:nvPr/>
         </p:nvSpPr>
@@ -1948,7 +2081,7 @@
       </p:sp>
       <p:sp>
         <p:nvSpPr>
-          <p:cNvPr id="9" name="Shape 7"/>
+          <p:cNvPr id="10" name="Shape 7"/>
           <p:cNvSpPr/>
           <p:nvPr/>
         </p:nvSpPr>
@@ -1970,7 +2103,7 @@
       </p:sp>
       <p:sp>
         <p:nvSpPr>
-          <p:cNvPr id="10" name="Text 8"/>
+          <p:cNvPr id="11" name="Text 8"/>
           <p:cNvSpPr txBox="1"/>
           <p:nvPr/>
         </p:nvSpPr>
@@ -2009,7 +2142,7 @@
       </p:sp>
       <p:sp>
         <p:nvSpPr>
-          <p:cNvPr id="11" name="Text 9"/>
+          <p:cNvPr id="12" name="Text 9"/>
           <p:cNvSpPr txBox="1"/>
           <p:nvPr/>
         </p:nvSpPr>
@@ -2048,7 +2181,7 @@
       </p:sp>
       <p:sp>
         <p:nvSpPr>
-          <p:cNvPr id="12" name="Shape 10"/>
+          <p:cNvPr id="13" name="Shape 10"/>
           <p:cNvSpPr/>
           <p:nvPr/>
         </p:nvSpPr>
@@ -2070,7 +2203,7 @@
       </p:sp>
       <p:sp>
         <p:nvSpPr>
-          <p:cNvPr id="13" name="Text 11"/>
+          <p:cNvPr id="14" name="Text 11"/>
           <p:cNvSpPr txBox="1"/>
           <p:nvPr/>
         </p:nvSpPr>
@@ -2109,7 +2242,7 @@
       </p:sp>
       <p:sp>
         <p:nvSpPr>
-          <p:cNvPr id="14" name="Text 12"/>
+          <p:cNvPr id="15" name="Text 12"/>
           <p:cNvSpPr txBox="1"/>
           <p:nvPr/>
         </p:nvSpPr>
@@ -2148,7 +2281,7 @@
       </p:sp>
       <p:sp>
         <p:nvSpPr>
-          <p:cNvPr id="15" name="Shape 13"/>
+          <p:cNvPr id="16" name="Shape 13"/>
           <p:cNvSpPr/>
           <p:nvPr/>
         </p:nvSpPr>
@@ -2163,14 +2296,14 @@
             </a:avLst>
           </a:prstGeom>
           <a:solidFill>
-            <a:srgbClr val="0F6AB4"/>
+            <a:srgbClr val="045292"/>
           </a:solidFill>
           <a:ln/>
         </p:spPr>
       </p:sp>
       <p:sp>
         <p:nvSpPr>
-          <p:cNvPr id="16" name="Text 14"/>
+          <p:cNvPr id="17" name="Text 14"/>
           <p:cNvSpPr txBox="1"/>
           <p:nvPr/>
         </p:nvSpPr>
@@ -2209,7 +2342,7 @@
       </p:sp>
       <p:sp>
         <p:nvSpPr>
-          <p:cNvPr id="17" name="Text 15"/>
+          <p:cNvPr id="18" name="Text 15"/>
           <p:cNvSpPr txBox="1"/>
           <p:nvPr/>
         </p:nvSpPr>
@@ -2248,7 +2381,7 @@
       </p:sp>
       <p:sp>
         <p:nvSpPr>
-          <p:cNvPr id="18" name="Text 16"/>
+          <p:cNvPr id="19" name="Text 16"/>
           <p:cNvSpPr txBox="1"/>
           <p:nvPr/>
         </p:nvSpPr>
@@ -2287,7 +2420,7 @@
       </p:sp>
       <p:sp>
         <p:nvSpPr>
-          <p:cNvPr id="19" name="Text 17"/>
+          <p:cNvPr id="20" name="Text 17"/>
           <p:cNvSpPr txBox="1"/>
           <p:nvPr/>
         </p:nvSpPr>
@@ -2356,9 +2489,33 @@
           <a:chExt cx="0" cy="0"/>
         </a:xfrm>
       </p:grpSpPr>
-      <p:sp>
-        <p:nvSpPr>
-          <p:cNvPr id="2" name="Text 0"/>
+      <p:pic>
+        <p:nvPicPr>
+          <p:cNvPr id="2" name="Image 0" descr="/tmp/claude-0/-home-user-takashima-yuto-site/d68be841-4a50-5410-afb9-fdf52bb655ee/scratchpad/sekisan/kcm_stripe.png">    </p:cNvPr>
+          <p:cNvPicPr>
+            <a:picLocks noChangeAspect="1"/>
+          </p:cNvPicPr>
+          <p:nvPr/>
+        </p:nvPicPr>
+        <p:blipFill>
+          <a:blip r:embed="rId1"/>
+          <a:stretch>
+            <a:fillRect/>
+          </a:stretch>
+        </p:blipFill>
+        <p:spPr>
+          <a:xfrm>
+            <a:off x="0" y="6656832"/>
+            <a:ext cx="12188952" cy="201168"/>
+          </a:xfrm>
+          <a:prstGeom prst="rect">
+            <a:avLst/>
+          </a:prstGeom>
+        </p:spPr>
+      </p:pic>
+      <p:sp>
+        <p:nvSpPr>
+          <p:cNvPr id="3" name="Text 0"/>
           <p:cNvSpPr txBox="1"/>
           <p:nvPr/>
         </p:nvSpPr>
@@ -2383,7 +2540,7 @@
             <a:r>
               <a:rPr lang="en-US" sz="2800" b="1" dirty="0">
                 <a:solidFill>
-                  <a:srgbClr val="1E2761"/>
+                  <a:srgbClr val="045292"/>
                 </a:solidFill>
                 <a:latin typeface="Meiryo UI" pitchFamily="34" charset="0"/>
                 <a:ea typeface="Meiryo UI" pitchFamily="34" charset="-122"/>
@@ -2397,7 +2554,7 @@
       </p:sp>
       <p:sp>
         <p:nvSpPr>
-          <p:cNvPr id="3" name="Shape 1"/>
+          <p:cNvPr id="4" name="Shape 1"/>
           <p:cNvSpPr/>
           <p:nvPr/>
         </p:nvSpPr>
@@ -2426,7 +2583,7 @@
       </p:sp>
       <p:sp>
         <p:nvSpPr>
-          <p:cNvPr id="4" name="Text 2"/>
+          <p:cNvPr id="5" name="Text 2"/>
           <p:cNvSpPr txBox="1"/>
           <p:nvPr/>
         </p:nvSpPr>
@@ -2465,7 +2622,7 @@
       </p:sp>
       <p:sp>
         <p:nvSpPr>
-          <p:cNvPr id="5" name="Text 3"/>
+          <p:cNvPr id="6" name="Text 3"/>
           <p:cNvSpPr txBox="1"/>
           <p:nvPr/>
         </p:nvSpPr>
@@ -2507,7 +2664,7 @@
       </p:sp>
       <p:sp>
         <p:nvSpPr>
-          <p:cNvPr id="6" name="Shape 4"/>
+          <p:cNvPr id="7" name="Shape 4"/>
           <p:cNvSpPr/>
           <p:nvPr/>
         </p:nvSpPr>
@@ -2536,7 +2693,7 @@
       </p:sp>
       <p:sp>
         <p:nvSpPr>
-          <p:cNvPr id="7" name="Text 5"/>
+          <p:cNvPr id="8" name="Text 5"/>
           <p:cNvSpPr txBox="1"/>
           <p:nvPr/>
         </p:nvSpPr>
@@ -2575,7 +2732,7 @@
       </p:sp>
       <p:sp>
         <p:nvSpPr>
-          <p:cNvPr id="8" name="Text 6"/>
+          <p:cNvPr id="9" name="Text 6"/>
           <p:cNvSpPr txBox="1"/>
           <p:nvPr/>
         </p:nvSpPr>
@@ -2617,7 +2774,7 @@
       </p:sp>
       <p:sp>
         <p:nvSpPr>
-          <p:cNvPr id="9" name="Shape 7"/>
+          <p:cNvPr id="10" name="Shape 7"/>
           <p:cNvSpPr/>
           <p:nvPr/>
         </p:nvSpPr>
@@ -2646,7 +2803,7 @@
       </p:sp>
       <p:sp>
         <p:nvSpPr>
-          <p:cNvPr id="10" name="Text 8"/>
+          <p:cNvPr id="11" name="Text 8"/>
           <p:cNvSpPr txBox="1"/>
           <p:nvPr/>
         </p:nvSpPr>
@@ -2685,7 +2842,7 @@
       </p:sp>
       <p:sp>
         <p:nvSpPr>
-          <p:cNvPr id="11" name="Text 9"/>
+          <p:cNvPr id="12" name="Text 9"/>
           <p:cNvSpPr txBox="1"/>
           <p:nvPr/>
         </p:nvSpPr>
@@ -2727,7 +2884,7 @@
       </p:sp>
       <p:sp>
         <p:nvSpPr>
-          <p:cNvPr id="12" name="Shape 10"/>
+          <p:cNvPr id="13" name="Shape 10"/>
           <p:cNvSpPr/>
           <p:nvPr/>
         </p:nvSpPr>
@@ -2756,7 +2913,7 @@
       </p:sp>
       <p:sp>
         <p:nvSpPr>
-          <p:cNvPr id="13" name="Text 11"/>
+          <p:cNvPr id="14" name="Text 11"/>
           <p:cNvSpPr txBox="1"/>
           <p:nvPr/>
         </p:nvSpPr>
@@ -2795,7 +2952,7 @@
       </p:sp>
       <p:sp>
         <p:nvSpPr>
-          <p:cNvPr id="14" name="Text 12"/>
+          <p:cNvPr id="15" name="Text 12"/>
           <p:cNvSpPr txBox="1"/>
           <p:nvPr/>
         </p:nvSpPr>
@@ -2837,7 +2994,7 @@
       </p:sp>
       <p:sp>
         <p:nvSpPr>
-          <p:cNvPr id="15" name="Text 13"/>
+          <p:cNvPr id="16" name="Text 13"/>
           <p:cNvSpPr txBox="1"/>
           <p:nvPr/>
         </p:nvSpPr>
@@ -2862,7 +3019,7 @@
             <a:r>
               <a:rPr lang="en-US" sz="1500" b="1" dirty="0">
                 <a:solidFill>
-                  <a:srgbClr val="1E2761"/>
+                  <a:srgbClr val="045292"/>
                 </a:solidFill>
                 <a:latin typeface="Meiryo UI" pitchFamily="34" charset="0"/>
                 <a:ea typeface="Meiryo UI" pitchFamily="34" charset="-122"/>
@@ -2876,7 +3033,7 @@
       </p:sp>
       <p:sp>
         <p:nvSpPr>
-          <p:cNvPr id="16" name="Text 14"/>
+          <p:cNvPr id="17" name="Text 14"/>
           <p:cNvSpPr txBox="1"/>
           <p:nvPr/>
         </p:nvSpPr>
@@ -2945,9 +3102,33 @@
           <a:chExt cx="0" cy="0"/>
         </a:xfrm>
       </p:grpSpPr>
-      <p:sp>
-        <p:nvSpPr>
-          <p:cNvPr id="2" name="Text 0"/>
+      <p:pic>
+        <p:nvPicPr>
+          <p:cNvPr id="2" name="Image 0" descr="/tmp/claude-0/-home-user-takashima-yuto-site/d68be841-4a50-5410-afb9-fdf52bb655ee/scratchpad/sekisan/kcm_stripe.png">    </p:cNvPr>
+          <p:cNvPicPr>
+            <a:picLocks noChangeAspect="1"/>
+          </p:cNvPicPr>
+          <p:nvPr/>
+        </p:nvPicPr>
+        <p:blipFill>
+          <a:blip r:embed="rId1"/>
+          <a:stretch>
+            <a:fillRect/>
+          </a:stretch>
+        </p:blipFill>
+        <p:spPr>
+          <a:xfrm>
+            <a:off x="0" y="6656832"/>
+            <a:ext cx="12188952" cy="201168"/>
+          </a:xfrm>
+          <a:prstGeom prst="rect">
+            <a:avLst/>
+          </a:prstGeom>
+        </p:spPr>
+      </p:pic>
+      <p:sp>
+        <p:nvSpPr>
+          <p:cNvPr id="3" name="Text 0"/>
           <p:cNvSpPr txBox="1"/>
           <p:nvPr/>
         </p:nvSpPr>
@@ -2972,7 +3153,7 @@
             <a:r>
               <a:rPr lang="en-US" sz="2800" b="1" dirty="0">
                 <a:solidFill>
-                  <a:srgbClr val="1E2761"/>
+                  <a:srgbClr val="045292"/>
                 </a:solidFill>
                 <a:latin typeface="Meiryo UI" pitchFamily="34" charset="0"/>
                 <a:ea typeface="Meiryo UI" pitchFamily="34" charset="-122"/>
@@ -2986,7 +3167,7 @@
       </p:sp>
       <p:sp>
         <p:nvSpPr>
-          <p:cNvPr id="3" name="Text 1"/>
+          <p:cNvPr id="4" name="Text 1"/>
           <p:cNvSpPr txBox="1"/>
           <p:nvPr/>
         </p:nvSpPr>
@@ -3025,7 +3206,7 @@
       </p:sp>
       <p:sp>
         <p:nvSpPr>
-          <p:cNvPr id="4" name="Shape 2"/>
+          <p:cNvPr id="5" name="Shape 2"/>
           <p:cNvSpPr/>
           <p:nvPr/>
         </p:nvSpPr>
@@ -3047,7 +3228,7 @@
       </p:sp>
       <p:sp>
         <p:nvSpPr>
-          <p:cNvPr id="5" name="Text 3"/>
+          <p:cNvPr id="6" name="Text 3"/>
           <p:cNvSpPr txBox="1"/>
           <p:nvPr/>
         </p:nvSpPr>
@@ -3103,7 +3284,7 @@
       </p:sp>
       <p:sp>
         <p:nvSpPr>
-          <p:cNvPr id="6" name="Text 4"/>
+          <p:cNvPr id="7" name="Text 4"/>
           <p:cNvSpPr txBox="1"/>
           <p:nvPr/>
         </p:nvSpPr>
@@ -3142,7 +3323,7 @@
       </p:sp>
       <p:sp>
         <p:nvSpPr>
-          <p:cNvPr id="7" name="Shape 5"/>
+          <p:cNvPr id="8" name="Shape 5"/>
           <p:cNvSpPr/>
           <p:nvPr/>
         </p:nvSpPr>
@@ -3164,7 +3345,7 @@
       </p:sp>
       <p:sp>
         <p:nvSpPr>
-          <p:cNvPr id="8" name="Text 6"/>
+          <p:cNvPr id="9" name="Text 6"/>
           <p:cNvSpPr txBox="1"/>
           <p:nvPr/>
         </p:nvSpPr>
@@ -3220,7 +3401,7 @@
       </p:sp>
       <p:sp>
         <p:nvSpPr>
-          <p:cNvPr id="9" name="Text 7"/>
+          <p:cNvPr id="10" name="Text 7"/>
           <p:cNvSpPr txBox="1"/>
           <p:nvPr/>
         </p:nvSpPr>
@@ -3259,7 +3440,7 @@
       </p:sp>
       <p:sp>
         <p:nvSpPr>
-          <p:cNvPr id="10" name="Shape 8"/>
+          <p:cNvPr id="11" name="Shape 8"/>
           <p:cNvSpPr/>
           <p:nvPr/>
         </p:nvSpPr>
@@ -3281,7 +3462,7 @@
       </p:sp>
       <p:sp>
         <p:nvSpPr>
-          <p:cNvPr id="11" name="Text 9"/>
+          <p:cNvPr id="12" name="Text 9"/>
           <p:cNvSpPr txBox="1"/>
           <p:nvPr/>
         </p:nvSpPr>
@@ -3337,7 +3518,7 @@
       </p:sp>
       <p:sp>
         <p:nvSpPr>
-          <p:cNvPr id="12" name="Text 10"/>
+          <p:cNvPr id="13" name="Text 10"/>
           <p:cNvSpPr txBox="1"/>
           <p:nvPr/>
         </p:nvSpPr>
@@ -3376,7 +3557,7 @@
       </p:sp>
       <p:sp>
         <p:nvSpPr>
-          <p:cNvPr id="13" name="Shape 11"/>
+          <p:cNvPr id="14" name="Shape 11"/>
           <p:cNvSpPr/>
           <p:nvPr/>
         </p:nvSpPr>
@@ -3398,7 +3579,7 @@
       </p:sp>
       <p:sp>
         <p:nvSpPr>
-          <p:cNvPr id="14" name="Text 12"/>
+          <p:cNvPr id="15" name="Text 12"/>
           <p:cNvSpPr txBox="1"/>
           <p:nvPr/>
         </p:nvSpPr>
@@ -3454,7 +3635,7 @@
       </p:sp>
       <p:sp>
         <p:nvSpPr>
-          <p:cNvPr id="15" name="Text 13"/>
+          <p:cNvPr id="16" name="Text 13"/>
           <p:cNvSpPr txBox="1"/>
           <p:nvPr/>
         </p:nvSpPr>
@@ -3493,7 +3674,7 @@
       </p:sp>
       <p:sp>
         <p:nvSpPr>
-          <p:cNvPr id="16" name="Shape 14"/>
+          <p:cNvPr id="17" name="Shape 14"/>
           <p:cNvSpPr/>
           <p:nvPr/>
         </p:nvSpPr>
@@ -3515,7 +3696,7 @@
       </p:sp>
       <p:sp>
         <p:nvSpPr>
-          <p:cNvPr id="17" name="Text 15"/>
+          <p:cNvPr id="18" name="Text 15"/>
           <p:cNvSpPr txBox="1"/>
           <p:nvPr/>
         </p:nvSpPr>
@@ -3571,7 +3752,7 @@
       </p:sp>
       <p:sp>
         <p:nvSpPr>
-          <p:cNvPr id="18" name="Text 16"/>
+          <p:cNvPr id="19" name="Text 16"/>
           <p:cNvSpPr txBox="1"/>
           <p:nvPr/>
         </p:nvSpPr>
@@ -3610,7 +3791,7 @@
       </p:sp>
       <p:sp>
         <p:nvSpPr>
-          <p:cNvPr id="19" name="Text 17"/>
+          <p:cNvPr id="20" name="Text 17"/>
           <p:cNvSpPr txBox="1"/>
           <p:nvPr/>
         </p:nvSpPr>
@@ -3635,7 +3816,7 @@
             <a:r>
               <a:rPr lang="en-US" sz="1500" b="1" dirty="0">
                 <a:solidFill>
-                  <a:srgbClr val="0F6AB4"/>
+                  <a:srgbClr val="045292"/>
                 </a:solidFill>
                 <a:latin typeface="Meiryo UI" pitchFamily="34" charset="0"/>
                 <a:ea typeface="Meiryo UI" pitchFamily="34" charset="-122"/>
@@ -3649,7 +3830,7 @@
       </p:sp>
       <p:sp>
         <p:nvSpPr>
-          <p:cNvPr id="20" name="Shape 18"/>
+          <p:cNvPr id="21" name="Shape 18"/>
           <p:cNvSpPr/>
           <p:nvPr/>
         </p:nvSpPr>
@@ -3671,7 +3852,7 @@
       </p:sp>
       <p:sp>
         <p:nvSpPr>
-          <p:cNvPr id="21" name="Text 19"/>
+          <p:cNvPr id="22" name="Text 19"/>
           <p:cNvSpPr txBox="1"/>
           <p:nvPr/>
         </p:nvSpPr>
@@ -3727,7 +3908,7 @@
       </p:sp>
       <p:sp>
         <p:nvSpPr>
-          <p:cNvPr id="22" name="Text 20"/>
+          <p:cNvPr id="23" name="Text 20"/>
           <p:cNvSpPr txBox="1"/>
           <p:nvPr/>
         </p:nvSpPr>
@@ -3752,7 +3933,7 @@
             <a:r>
               <a:rPr lang="en-US" sz="1200" dirty="0">
                 <a:solidFill>
-                  <a:srgbClr val="0F6AB4"/>
+                  <a:srgbClr val="045292"/>
                 </a:solidFill>
                 <a:latin typeface="Meiryo UI" pitchFamily="34" charset="0"/>
                 <a:ea typeface="Meiryo UI" pitchFamily="34" charset="-122"/>
@@ -3766,7 +3947,7 @@
       </p:sp>
       <p:sp>
         <p:nvSpPr>
-          <p:cNvPr id="23" name="Shape 21"/>
+          <p:cNvPr id="24" name="Shape 21"/>
           <p:cNvSpPr/>
           <p:nvPr/>
         </p:nvSpPr>
@@ -3788,7 +3969,7 @@
       </p:sp>
       <p:sp>
         <p:nvSpPr>
-          <p:cNvPr id="24" name="Text 22"/>
+          <p:cNvPr id="25" name="Text 22"/>
           <p:cNvSpPr txBox="1"/>
           <p:nvPr/>
         </p:nvSpPr>
@@ -3844,7 +4025,7 @@
       </p:sp>
       <p:sp>
         <p:nvSpPr>
-          <p:cNvPr id="25" name="Text 23"/>
+          <p:cNvPr id="26" name="Text 23"/>
           <p:cNvSpPr txBox="1"/>
           <p:nvPr/>
         </p:nvSpPr>
@@ -3869,7 +4050,7 @@
             <a:r>
               <a:rPr lang="en-US" sz="1200" dirty="0">
                 <a:solidFill>
-                  <a:srgbClr val="0F6AB4"/>
+                  <a:srgbClr val="045292"/>
                 </a:solidFill>
                 <a:latin typeface="Meiryo UI" pitchFamily="34" charset="0"/>
                 <a:ea typeface="Meiryo UI" pitchFamily="34" charset="-122"/>
@@ -3883,7 +4064,7 @@
       </p:sp>
       <p:sp>
         <p:nvSpPr>
-          <p:cNvPr id="26" name="Shape 24"/>
+          <p:cNvPr id="27" name="Shape 24"/>
           <p:cNvSpPr/>
           <p:nvPr/>
         </p:nvSpPr>
@@ -3905,7 +4086,7 @@
       </p:sp>
       <p:sp>
         <p:nvSpPr>
-          <p:cNvPr id="27" name="Text 25"/>
+          <p:cNvPr id="28" name="Text 25"/>
           <p:cNvSpPr txBox="1"/>
           <p:nvPr/>
         </p:nvSpPr>
@@ -3961,7 +4142,7 @@
       </p:sp>
       <p:sp>
         <p:nvSpPr>
-          <p:cNvPr id="28" name="Text 26"/>
+          <p:cNvPr id="29" name="Text 26"/>
           <p:cNvSpPr txBox="1"/>
           <p:nvPr/>
         </p:nvSpPr>
@@ -3986,7 +4167,7 @@
             <a:r>
               <a:rPr lang="en-US" sz="1200" dirty="0">
                 <a:solidFill>
-                  <a:srgbClr val="0F6AB4"/>
+                  <a:srgbClr val="045292"/>
                 </a:solidFill>
                 <a:latin typeface="Meiryo UI" pitchFamily="34" charset="0"/>
                 <a:ea typeface="Meiryo UI" pitchFamily="34" charset="-122"/>
@@ -4000,7 +4181,7 @@
       </p:sp>
       <p:sp>
         <p:nvSpPr>
-          <p:cNvPr id="29" name="Shape 27"/>
+          <p:cNvPr id="30" name="Shape 27"/>
           <p:cNvSpPr/>
           <p:nvPr/>
         </p:nvSpPr>
@@ -4022,7 +4203,7 @@
       </p:sp>
       <p:sp>
         <p:nvSpPr>
-          <p:cNvPr id="30" name="Text 28"/>
+          <p:cNvPr id="31" name="Text 28"/>
           <p:cNvSpPr txBox="1"/>
           <p:nvPr/>
         </p:nvSpPr>
@@ -4078,7 +4259,7 @@
       </p:sp>
       <p:sp>
         <p:nvSpPr>
-          <p:cNvPr id="31" name="Text 29"/>
+          <p:cNvPr id="32" name="Text 29"/>
           <p:cNvSpPr txBox="1"/>
           <p:nvPr/>
         </p:nvSpPr>
@@ -4103,7 +4284,7 @@
             <a:r>
               <a:rPr lang="en-US" sz="1450" b="1" dirty="0">
                 <a:solidFill>
-                  <a:srgbClr val="0F6AB4"/>
+                  <a:srgbClr val="045292"/>
                 </a:solidFill>
                 <a:latin typeface="Meiryo UI" pitchFamily="34" charset="0"/>
                 <a:ea typeface="Meiryo UI" pitchFamily="34" charset="-122"/>
@@ -4131,7 +4312,7 @@
       </p:sp>
       <p:sp>
         <p:nvSpPr>
-          <p:cNvPr id="32" name="Text 30"/>
+          <p:cNvPr id="33" name="Text 30"/>
           <p:cNvSpPr txBox="1"/>
           <p:nvPr/>
         </p:nvSpPr>
@@ -4156,7 +4337,7 @@
             <a:r>
               <a:rPr lang="en-US" sz="1450" b="1" dirty="0">
                 <a:solidFill>
-                  <a:srgbClr val="0F6AB4"/>
+                  <a:srgbClr val="045292"/>
                 </a:solidFill>
                 <a:latin typeface="Meiryo UI" pitchFamily="34" charset="0"/>
                 <a:ea typeface="Meiryo UI" pitchFamily="34" charset="-122"/>
@@ -4184,7 +4365,7 @@
       </p:sp>
       <p:sp>
         <p:nvSpPr>
-          <p:cNvPr id="33" name="Text 31"/>
+          <p:cNvPr id="34" name="Text 31"/>
           <p:cNvSpPr txBox="1"/>
           <p:nvPr/>
         </p:nvSpPr>
@@ -4209,7 +4390,7 @@
             <a:r>
               <a:rPr lang="en-US" sz="1450" b="1" dirty="0">
                 <a:solidFill>
-                  <a:srgbClr val="0F6AB4"/>
+                  <a:srgbClr val="045292"/>
                 </a:solidFill>
                 <a:latin typeface="Meiryo UI" pitchFamily="34" charset="0"/>
                 <a:ea typeface="Meiryo UI" pitchFamily="34" charset="-122"/>
@@ -4237,7 +4418,7 @@
       </p:sp>
       <p:sp>
         <p:nvSpPr>
-          <p:cNvPr id="34" name="Text 32"/>
+          <p:cNvPr id="35" name="Text 32"/>
           <p:cNvSpPr txBox="1"/>
           <p:nvPr/>
         </p:nvSpPr>
@@ -4306,48 +4487,9 @@
           <a:chExt cx="0" cy="0"/>
         </a:xfrm>
       </p:grpSpPr>
-      <p:sp>
-        <p:nvSpPr>
-          <p:cNvPr id="2" name="Text 0"/>
-          <p:cNvSpPr txBox="1"/>
-          <p:nvPr/>
-        </p:nvSpPr>
-        <p:spPr>
-          <a:xfrm>
-            <a:off x="548640" y="384048"/>
-            <a:ext cx="11064240" cy="685800"/>
-          </a:xfrm>
-          <a:prstGeom prst="rect">
-            <a:avLst/>
-          </a:prstGeom>
-          <a:noFill/>
-          <a:ln/>
-        </p:spPr>
-        <p:txBody>
-          <a:bodyPr wrap="square" lIns="0" tIns="0" rIns="0" bIns="0" rtlCol="0" anchor="ctr"/>
-          <a:lstStyle/>
-          <a:p>
-            <a:pPr indent="0" marL="0">
-              <a:buNone/>
-            </a:pPr>
-            <a:r>
-              <a:rPr lang="en-US" sz="2800" b="1" dirty="0">
-                <a:solidFill>
-                  <a:srgbClr val="1E2761"/>
-                </a:solidFill>
-                <a:latin typeface="Meiryo UI" pitchFamily="34" charset="0"/>
-                <a:ea typeface="Meiryo UI" pitchFamily="34" charset="-122"/>
-                <a:cs typeface="Meiryo UI" pitchFamily="34" charset="-120"/>
-              </a:rPr>
-              <a:t>画面イメージ　―　設計積算条件リストの確認・入力</a:t>
-            </a:r>
-            <a:endParaRPr lang="en-US" sz="2800" dirty="0"/>
-          </a:p>
-        </p:txBody>
-      </p:sp>
       <p:pic>
         <p:nvPicPr>
-          <p:cNvPr id="3" name="Image 0" descr="shots/03_editor.png">    </p:cNvPr>
+          <p:cNvPr id="2" name="Image 0" descr="/tmp/claude-0/-home-user-takashima-yuto-site/d68be841-4a50-5410-afb9-fdf52bb655ee/scratchpad/sekisan/kcm_stripe.png">    </p:cNvPr>
           <p:cNvPicPr>
             <a:picLocks noChangeAspect="1"/>
           </p:cNvPicPr>
@@ -4361,6 +4503,69 @@
         </p:blipFill>
         <p:spPr>
           <a:xfrm>
+            <a:off x="0" y="6656832"/>
+            <a:ext cx="12188952" cy="201168"/>
+          </a:xfrm>
+          <a:prstGeom prst="rect">
+            <a:avLst/>
+          </a:prstGeom>
+        </p:spPr>
+      </p:pic>
+      <p:sp>
+        <p:nvSpPr>
+          <p:cNvPr id="3" name="Text 0"/>
+          <p:cNvSpPr txBox="1"/>
+          <p:nvPr/>
+        </p:nvSpPr>
+        <p:spPr>
+          <a:xfrm>
+            <a:off x="548640" y="384048"/>
+            <a:ext cx="11064240" cy="685800"/>
+          </a:xfrm>
+          <a:prstGeom prst="rect">
+            <a:avLst/>
+          </a:prstGeom>
+          <a:noFill/>
+          <a:ln/>
+        </p:spPr>
+        <p:txBody>
+          <a:bodyPr wrap="square" lIns="0" tIns="0" rIns="0" bIns="0" rtlCol="0" anchor="ctr"/>
+          <a:lstStyle/>
+          <a:p>
+            <a:pPr indent="0" marL="0">
+              <a:buNone/>
+            </a:pPr>
+            <a:r>
+              <a:rPr lang="en-US" sz="2800" b="1" dirty="0">
+                <a:solidFill>
+                  <a:srgbClr val="045292"/>
+                </a:solidFill>
+                <a:latin typeface="Meiryo UI" pitchFamily="34" charset="0"/>
+                <a:ea typeface="Meiryo UI" pitchFamily="34" charset="-122"/>
+                <a:cs typeface="Meiryo UI" pitchFamily="34" charset="-120"/>
+              </a:rPr>
+              <a:t>画面イメージ　―　設計積算条件リストの確認・入力</a:t>
+            </a:r>
+            <a:endParaRPr lang="en-US" sz="2800" dirty="0"/>
+          </a:p>
+        </p:txBody>
+      </p:sp>
+      <p:pic>
+        <p:nvPicPr>
+          <p:cNvPr id="4" name="Image 1" descr="shots/03_editor.png">    </p:cNvPr>
+          <p:cNvPicPr>
+            <a:picLocks noChangeAspect="1"/>
+          </p:cNvPicPr>
+          <p:nvPr/>
+        </p:nvPicPr>
+        <p:blipFill>
+          <a:blip r:embed="rId2"/>
+          <a:stretch>
+            <a:fillRect/>
+          </a:stretch>
+        </p:blipFill>
+        <p:spPr>
+          <a:xfrm>
             <a:off x="548640" y="1325880"/>
             <a:ext cx="7863840" cy="6184311"/>
           </a:xfrm>
@@ -4378,7 +4583,7 @@
       </p:pic>
       <p:sp>
         <p:nvSpPr>
-          <p:cNvPr id="4" name="Shape 1"/>
+          <p:cNvPr id="5" name="Shape 1"/>
           <p:cNvSpPr/>
           <p:nvPr/>
         </p:nvSpPr>
@@ -4400,7 +4605,7 @@
       </p:sp>
       <p:sp>
         <p:nvSpPr>
-          <p:cNvPr id="5" name="Text 2"/>
+          <p:cNvPr id="6" name="Text 2"/>
           <p:cNvSpPr txBox="1"/>
           <p:nvPr/>
         </p:nvSpPr>
@@ -4425,7 +4630,7 @@
             <a:r>
               <a:rPr lang="en-US" sz="1250" b="1" dirty="0">
                 <a:solidFill>
-                  <a:srgbClr val="1E2761"/>
+                  <a:srgbClr val="045292"/>
                 </a:solidFill>
                 <a:latin typeface="Meiryo UI" pitchFamily="34" charset="0"/>
                 <a:ea typeface="Meiryo UI" pitchFamily="34" charset="-122"/>
@@ -4439,7 +4644,7 @@
       </p:sp>
       <p:sp>
         <p:nvSpPr>
-          <p:cNvPr id="6" name="Text 3"/>
+          <p:cNvPr id="7" name="Text 3"/>
           <p:cNvSpPr txBox="1"/>
           <p:nvPr/>
         </p:nvSpPr>
@@ -4481,7 +4686,7 @@
       </p:sp>
       <p:sp>
         <p:nvSpPr>
-          <p:cNvPr id="7" name="Shape 4"/>
+          <p:cNvPr id="8" name="Shape 4"/>
           <p:cNvSpPr/>
           <p:nvPr/>
         </p:nvSpPr>
@@ -4503,7 +4708,7 @@
       </p:sp>
       <p:sp>
         <p:nvSpPr>
-          <p:cNvPr id="8" name="Text 5"/>
+          <p:cNvPr id="9" name="Text 5"/>
           <p:cNvSpPr txBox="1"/>
           <p:nvPr/>
         </p:nvSpPr>
@@ -4528,7 +4733,7 @@
             <a:r>
               <a:rPr lang="en-US" sz="1250" b="1" dirty="0">
                 <a:solidFill>
-                  <a:srgbClr val="1E2761"/>
+                  <a:srgbClr val="045292"/>
                 </a:solidFill>
                 <a:latin typeface="Meiryo UI" pitchFamily="34" charset="0"/>
                 <a:ea typeface="Meiryo UI" pitchFamily="34" charset="-122"/>
@@ -4542,7 +4747,7 @@
       </p:sp>
       <p:sp>
         <p:nvSpPr>
-          <p:cNvPr id="9" name="Text 6"/>
+          <p:cNvPr id="10" name="Text 6"/>
           <p:cNvSpPr txBox="1"/>
           <p:nvPr/>
         </p:nvSpPr>
@@ -4584,7 +4789,7 @@
       </p:sp>
       <p:sp>
         <p:nvSpPr>
-          <p:cNvPr id="10" name="Shape 7"/>
+          <p:cNvPr id="11" name="Shape 7"/>
           <p:cNvSpPr/>
           <p:nvPr/>
         </p:nvSpPr>
@@ -4606,7 +4811,7 @@
       </p:sp>
       <p:sp>
         <p:nvSpPr>
-          <p:cNvPr id="11" name="Text 8"/>
+          <p:cNvPr id="12" name="Text 8"/>
           <p:cNvSpPr txBox="1"/>
           <p:nvPr/>
         </p:nvSpPr>
@@ -4631,7 +4836,7 @@
             <a:r>
               <a:rPr lang="en-US" sz="1250" b="1" dirty="0">
                 <a:solidFill>
-                  <a:srgbClr val="1E2761"/>
+                  <a:srgbClr val="045292"/>
                 </a:solidFill>
                 <a:latin typeface="Meiryo UI" pitchFamily="34" charset="0"/>
                 <a:ea typeface="Meiryo UI" pitchFamily="34" charset="-122"/>
@@ -4645,7 +4850,7 @@
       </p:sp>
       <p:sp>
         <p:nvSpPr>
-          <p:cNvPr id="12" name="Text 9"/>
+          <p:cNvPr id="13" name="Text 9"/>
           <p:cNvSpPr txBox="1"/>
           <p:nvPr/>
         </p:nvSpPr>
@@ -4687,7 +4892,7 @@
       </p:sp>
       <p:sp>
         <p:nvSpPr>
-          <p:cNvPr id="13" name="Shape 10"/>
+          <p:cNvPr id="14" name="Shape 10"/>
           <p:cNvSpPr/>
           <p:nvPr/>
         </p:nvSpPr>
@@ -4709,7 +4914,7 @@
       </p:sp>
       <p:sp>
         <p:nvSpPr>
-          <p:cNvPr id="14" name="Text 11"/>
+          <p:cNvPr id="15" name="Text 11"/>
           <p:cNvSpPr txBox="1"/>
           <p:nvPr/>
         </p:nvSpPr>
@@ -4734,7 +4939,7 @@
             <a:r>
               <a:rPr lang="en-US" sz="1250" b="1" dirty="0">
                 <a:solidFill>
-                  <a:srgbClr val="1E2761"/>
+                  <a:srgbClr val="045292"/>
                 </a:solidFill>
                 <a:latin typeface="Meiryo UI" pitchFamily="34" charset="0"/>
                 <a:ea typeface="Meiryo UI" pitchFamily="34" charset="-122"/>
@@ -4748,7 +4953,7 @@
       </p:sp>
       <p:sp>
         <p:nvSpPr>
-          <p:cNvPr id="15" name="Text 12"/>
+          <p:cNvPr id="16" name="Text 12"/>
           <p:cNvSpPr txBox="1"/>
           <p:nvPr/>
         </p:nvSpPr>
@@ -4790,7 +4995,7 @@
       </p:sp>
       <p:sp>
         <p:nvSpPr>
-          <p:cNvPr id="16" name="Text 13"/>
+          <p:cNvPr id="17" name="Text 13"/>
           <p:cNvSpPr txBox="1"/>
           <p:nvPr/>
         </p:nvSpPr>
@@ -4859,9 +5064,33 @@
           <a:chExt cx="0" cy="0"/>
         </a:xfrm>
       </p:grpSpPr>
-      <p:sp>
-        <p:nvSpPr>
-          <p:cNvPr id="2" name="Text 0"/>
+      <p:pic>
+        <p:nvPicPr>
+          <p:cNvPr id="2" name="Image 0" descr="/tmp/claude-0/-home-user-takashima-yuto-site/d68be841-4a50-5410-afb9-fdf52bb655ee/scratchpad/sekisan/kcm_stripe.png">    </p:cNvPr>
+          <p:cNvPicPr>
+            <a:picLocks noChangeAspect="1"/>
+          </p:cNvPicPr>
+          <p:nvPr/>
+        </p:nvPicPr>
+        <p:blipFill>
+          <a:blip r:embed="rId1"/>
+          <a:stretch>
+            <a:fillRect/>
+          </a:stretch>
+        </p:blipFill>
+        <p:spPr>
+          <a:xfrm>
+            <a:off x="0" y="6656832"/>
+            <a:ext cx="12188952" cy="201168"/>
+          </a:xfrm>
+          <a:prstGeom prst="rect">
+            <a:avLst/>
+          </a:prstGeom>
+        </p:spPr>
+      </p:pic>
+      <p:sp>
+        <p:nvSpPr>
+          <p:cNvPr id="3" name="Text 0"/>
           <p:cNvSpPr txBox="1"/>
           <p:nvPr/>
         </p:nvSpPr>
@@ -4886,7 +5115,7 @@
             <a:r>
               <a:rPr lang="en-US" sz="2800" b="1" dirty="0">
                 <a:solidFill>
-                  <a:srgbClr val="1E2761"/>
+                  <a:srgbClr val="045292"/>
                 </a:solidFill>
                 <a:latin typeface="Meiryo UI" pitchFamily="34" charset="0"/>
                 <a:ea typeface="Meiryo UI" pitchFamily="34" charset="-122"/>
@@ -4900,7 +5129,7 @@
       </p:sp>
       <p:sp>
         <p:nvSpPr>
-          <p:cNvPr id="3" name="Shape 1"/>
+          <p:cNvPr id="4" name="Shape 1"/>
           <p:cNvSpPr/>
           <p:nvPr/>
         </p:nvSpPr>
@@ -4922,7 +5151,7 @@
       </p:sp>
       <p:sp>
         <p:nvSpPr>
-          <p:cNvPr id="4" name="Text 2"/>
+          <p:cNvPr id="5" name="Text 2"/>
           <p:cNvSpPr txBox="1"/>
           <p:nvPr/>
         </p:nvSpPr>
@@ -4947,7 +5176,7 @@
             <a:r>
               <a:rPr lang="en-US" sz="1700" b="1" dirty="0">
                 <a:solidFill>
-                  <a:srgbClr val="1E2761"/>
+                  <a:srgbClr val="045292"/>
                 </a:solidFill>
                 <a:latin typeface="Meiryo UI" pitchFamily="34" charset="0"/>
                 <a:ea typeface="Meiryo UI" pitchFamily="34" charset="-122"/>
@@ -4961,7 +5190,7 @@
       </p:sp>
       <p:sp>
         <p:nvSpPr>
-          <p:cNvPr id="5" name="Text 3"/>
+          <p:cNvPr id="6" name="Text 3"/>
           <p:cNvSpPr txBox="1"/>
           <p:nvPr/>
         </p:nvSpPr>
@@ -5000,7 +5229,7 @@
       </p:sp>
       <p:sp>
         <p:nvSpPr>
-          <p:cNvPr id="6" name="Shape 4"/>
+          <p:cNvPr id="7" name="Shape 4"/>
           <p:cNvSpPr/>
           <p:nvPr/>
         </p:nvSpPr>
@@ -5022,7 +5251,7 @@
       </p:sp>
       <p:sp>
         <p:nvSpPr>
-          <p:cNvPr id="7" name="Text 5"/>
+          <p:cNvPr id="8" name="Text 5"/>
           <p:cNvSpPr txBox="1"/>
           <p:nvPr/>
         </p:nvSpPr>
@@ -5047,7 +5276,7 @@
             <a:r>
               <a:rPr lang="en-US" sz="1700" b="1" dirty="0">
                 <a:solidFill>
-                  <a:srgbClr val="1E2761"/>
+                  <a:srgbClr val="045292"/>
                 </a:solidFill>
                 <a:latin typeface="Meiryo UI" pitchFamily="34" charset="0"/>
                 <a:ea typeface="Meiryo UI" pitchFamily="34" charset="-122"/>
@@ -5061,7 +5290,7 @@
       </p:sp>
       <p:sp>
         <p:nvSpPr>
-          <p:cNvPr id="8" name="Text 6"/>
+          <p:cNvPr id="9" name="Text 6"/>
           <p:cNvSpPr txBox="1"/>
           <p:nvPr/>
         </p:nvSpPr>
@@ -5100,7 +5329,7 @@
       </p:sp>
       <p:sp>
         <p:nvSpPr>
-          <p:cNvPr id="9" name="Shape 7"/>
+          <p:cNvPr id="10" name="Shape 7"/>
           <p:cNvSpPr/>
           <p:nvPr/>
         </p:nvSpPr>
@@ -5122,7 +5351,7 @@
       </p:sp>
       <p:sp>
         <p:nvSpPr>
-          <p:cNvPr id="10" name="Text 8"/>
+          <p:cNvPr id="11" name="Text 8"/>
           <p:cNvSpPr txBox="1"/>
           <p:nvPr/>
         </p:nvSpPr>
@@ -5147,7 +5376,7 @@
             <a:r>
               <a:rPr lang="en-US" sz="1700" b="1" dirty="0">
                 <a:solidFill>
-                  <a:srgbClr val="1E2761"/>
+                  <a:srgbClr val="045292"/>
                 </a:solidFill>
                 <a:latin typeface="Meiryo UI" pitchFamily="34" charset="0"/>
                 <a:ea typeface="Meiryo UI" pitchFamily="34" charset="-122"/>
@@ -5161,7 +5390,7 @@
       </p:sp>
       <p:sp>
         <p:nvSpPr>
-          <p:cNvPr id="11" name="Text 9"/>
+          <p:cNvPr id="12" name="Text 9"/>
           <p:cNvSpPr txBox="1"/>
           <p:nvPr/>
         </p:nvSpPr>
@@ -5200,7 +5429,7 @@
       </p:sp>
       <p:sp>
         <p:nvSpPr>
-          <p:cNvPr id="12" name="Shape 10"/>
+          <p:cNvPr id="13" name="Shape 10"/>
           <p:cNvSpPr/>
           <p:nvPr/>
         </p:nvSpPr>
@@ -5222,7 +5451,7 @@
       </p:sp>
       <p:sp>
         <p:nvSpPr>
-          <p:cNvPr id="13" name="Text 11"/>
+          <p:cNvPr id="14" name="Text 11"/>
           <p:cNvSpPr txBox="1"/>
           <p:nvPr/>
         </p:nvSpPr>
@@ -5247,7 +5476,7 @@
             <a:r>
               <a:rPr lang="en-US" sz="1700" b="1" dirty="0">
                 <a:solidFill>
-                  <a:srgbClr val="1E2761"/>
+                  <a:srgbClr val="045292"/>
                 </a:solidFill>
                 <a:latin typeface="Meiryo UI" pitchFamily="34" charset="0"/>
                 <a:ea typeface="Meiryo UI" pitchFamily="34" charset="-122"/>
@@ -5261,7 +5490,7 @@
       </p:sp>
       <p:sp>
         <p:nvSpPr>
-          <p:cNvPr id="14" name="Text 12"/>
+          <p:cNvPr id="15" name="Text 12"/>
           <p:cNvSpPr txBox="1"/>
           <p:nvPr/>
         </p:nvSpPr>
@@ -5300,7 +5529,7 @@
       </p:sp>
       <p:sp>
         <p:nvSpPr>
-          <p:cNvPr id="15" name="Text 13"/>
+          <p:cNvPr id="16" name="Text 13"/>
           <p:cNvSpPr txBox="1"/>
           <p:nvPr/>
         </p:nvSpPr>
@@ -5339,7 +5568,7 @@
       </p:sp>
       <p:sp>
         <p:nvSpPr>
-          <p:cNvPr id="16" name="Text 14"/>
+          <p:cNvPr id="17" name="Text 14"/>
           <p:cNvSpPr txBox="1"/>
           <p:nvPr/>
         </p:nvSpPr>
@@ -5408,9 +5637,33 @@
           <a:chExt cx="0" cy="0"/>
         </a:xfrm>
       </p:grpSpPr>
-      <p:sp>
-        <p:nvSpPr>
-          <p:cNvPr id="2" name="Text 0"/>
+      <p:pic>
+        <p:nvPicPr>
+          <p:cNvPr id="2" name="Image 0" descr="/tmp/claude-0/-home-user-takashima-yuto-site/d68be841-4a50-5410-afb9-fdf52bb655ee/scratchpad/sekisan/kcm_stripe.png">    </p:cNvPr>
+          <p:cNvPicPr>
+            <a:picLocks noChangeAspect="1"/>
+          </p:cNvPicPr>
+          <p:nvPr/>
+        </p:nvPicPr>
+        <p:blipFill>
+          <a:blip r:embed="rId1"/>
+          <a:stretch>
+            <a:fillRect/>
+          </a:stretch>
+        </p:blipFill>
+        <p:spPr>
+          <a:xfrm>
+            <a:off x="0" y="6656832"/>
+            <a:ext cx="12188952" cy="201168"/>
+          </a:xfrm>
+          <a:prstGeom prst="rect">
+            <a:avLst/>
+          </a:prstGeom>
+        </p:spPr>
+      </p:pic>
+      <p:sp>
+        <p:nvSpPr>
+          <p:cNvPr id="3" name="Text 0"/>
           <p:cNvSpPr txBox="1"/>
           <p:nvPr/>
         </p:nvSpPr>
@@ -5435,7 +5688,7 @@
             <a:r>
               <a:rPr lang="en-US" sz="2800" b="1" dirty="0">
                 <a:solidFill>
-                  <a:srgbClr val="1E2761"/>
+                  <a:srgbClr val="045292"/>
                 </a:solidFill>
                 <a:latin typeface="Meiryo UI" pitchFamily="34" charset="0"/>
                 <a:ea typeface="Meiryo UI" pitchFamily="34" charset="-122"/>
@@ -5449,7 +5702,7 @@
       </p:sp>
       <p:sp>
         <p:nvSpPr>
-          <p:cNvPr id="3" name="Shape 1"/>
+          <p:cNvPr id="4" name="Shape 1"/>
           <p:cNvSpPr/>
           <p:nvPr/>
         </p:nvSpPr>
@@ -5478,7 +5731,7 @@
       </p:sp>
       <p:sp>
         <p:nvSpPr>
-          <p:cNvPr id="4" name="Shape 2"/>
+          <p:cNvPr id="5" name="Shape 2"/>
           <p:cNvSpPr/>
           <p:nvPr/>
         </p:nvSpPr>
@@ -5491,14 +5744,14 @@
             <a:avLst/>
           </a:prstGeom>
           <a:solidFill>
-            <a:srgbClr val="1E2761"/>
+            <a:srgbClr val="045292"/>
           </a:solidFill>
           <a:ln/>
         </p:spPr>
       </p:sp>
       <p:sp>
         <p:nvSpPr>
-          <p:cNvPr id="5" name="Text 3"/>
+          <p:cNvPr id="6" name="Text 3"/>
           <p:cNvSpPr txBox="1"/>
           <p:nvPr/>
         </p:nvSpPr>
@@ -5537,7 +5790,7 @@
       </p:sp>
       <p:sp>
         <p:nvSpPr>
-          <p:cNvPr id="6" name="Text 4"/>
+          <p:cNvPr id="7" name="Text 4"/>
           <p:cNvSpPr txBox="1"/>
           <p:nvPr/>
         </p:nvSpPr>
@@ -5562,7 +5815,7 @@
             <a:r>
               <a:rPr lang="en-US" sz="1650" b="1" dirty="0">
                 <a:solidFill>
-                  <a:srgbClr val="1E2761"/>
+                  <a:srgbClr val="045292"/>
                 </a:solidFill>
                 <a:latin typeface="Meiryo UI" pitchFamily="34" charset="0"/>
                 <a:ea typeface="Meiryo UI" pitchFamily="34" charset="-122"/>
@@ -5576,7 +5829,7 @@
       </p:sp>
       <p:sp>
         <p:nvSpPr>
-          <p:cNvPr id="7" name="Text 5"/>
+          <p:cNvPr id="8" name="Text 5"/>
           <p:cNvSpPr txBox="1"/>
           <p:nvPr/>
         </p:nvSpPr>
@@ -5618,7 +5871,7 @@
       </p:sp>
       <p:sp>
         <p:nvSpPr>
-          <p:cNvPr id="8" name="Shape 6"/>
+          <p:cNvPr id="9" name="Shape 6"/>
           <p:cNvSpPr/>
           <p:nvPr/>
         </p:nvSpPr>
@@ -5647,7 +5900,7 @@
       </p:sp>
       <p:sp>
         <p:nvSpPr>
-          <p:cNvPr id="9" name="Shape 7"/>
+          <p:cNvPr id="10" name="Shape 7"/>
           <p:cNvSpPr/>
           <p:nvPr/>
         </p:nvSpPr>
@@ -5660,14 +5913,14 @@
             <a:avLst/>
           </a:prstGeom>
           <a:solidFill>
-            <a:srgbClr val="1E2761"/>
+            <a:srgbClr val="045292"/>
           </a:solidFill>
           <a:ln/>
         </p:spPr>
       </p:sp>
       <p:sp>
         <p:nvSpPr>
-          <p:cNvPr id="10" name="Text 8"/>
+          <p:cNvPr id="11" name="Text 8"/>
           <p:cNvSpPr txBox="1"/>
           <p:nvPr/>
         </p:nvSpPr>
@@ -5706,7 +5959,7 @@
       </p:sp>
       <p:sp>
         <p:nvSpPr>
-          <p:cNvPr id="11" name="Text 9"/>
+          <p:cNvPr id="12" name="Text 9"/>
           <p:cNvSpPr txBox="1"/>
           <p:nvPr/>
         </p:nvSpPr>
@@ -5731,7 +5984,7 @@
             <a:r>
               <a:rPr lang="en-US" sz="1650" b="1" dirty="0">
                 <a:solidFill>
-                  <a:srgbClr val="1E2761"/>
+                  <a:srgbClr val="045292"/>
                 </a:solidFill>
                 <a:latin typeface="Meiryo UI" pitchFamily="34" charset="0"/>
                 <a:ea typeface="Meiryo UI" pitchFamily="34" charset="-122"/>
@@ -5745,7 +5998,7 @@
       </p:sp>
       <p:sp>
         <p:nvSpPr>
-          <p:cNvPr id="12" name="Text 10"/>
+          <p:cNvPr id="13" name="Text 10"/>
           <p:cNvSpPr txBox="1"/>
           <p:nvPr/>
         </p:nvSpPr>
@@ -5787,7 +6040,7 @@
       </p:sp>
       <p:sp>
         <p:nvSpPr>
-          <p:cNvPr id="13" name="Shape 11"/>
+          <p:cNvPr id="14" name="Shape 11"/>
           <p:cNvSpPr/>
           <p:nvPr/>
         </p:nvSpPr>
@@ -5816,7 +6069,7 @@
       </p:sp>
       <p:sp>
         <p:nvSpPr>
-          <p:cNvPr id="14" name="Shape 12"/>
+          <p:cNvPr id="15" name="Shape 12"/>
           <p:cNvSpPr/>
           <p:nvPr/>
         </p:nvSpPr>
@@ -5829,14 +6082,14 @@
             <a:avLst/>
           </a:prstGeom>
           <a:solidFill>
-            <a:srgbClr val="1E2761"/>
+            <a:srgbClr val="045292"/>
           </a:solidFill>
           <a:ln/>
         </p:spPr>
       </p:sp>
       <p:sp>
         <p:nvSpPr>
-          <p:cNvPr id="15" name="Text 13"/>
+          <p:cNvPr id="16" name="Text 13"/>
           <p:cNvSpPr txBox="1"/>
           <p:nvPr/>
         </p:nvSpPr>
@@ -5875,7 +6128,7 @@
       </p:sp>
       <p:sp>
         <p:nvSpPr>
-          <p:cNvPr id="16" name="Text 14"/>
+          <p:cNvPr id="17" name="Text 14"/>
           <p:cNvSpPr txBox="1"/>
           <p:nvPr/>
         </p:nvSpPr>
@@ -5900,7 +6153,7 @@
             <a:r>
               <a:rPr lang="en-US" sz="1650" b="1" dirty="0">
                 <a:solidFill>
-                  <a:srgbClr val="1E2761"/>
+                  <a:srgbClr val="045292"/>
                 </a:solidFill>
                 <a:latin typeface="Meiryo UI" pitchFamily="34" charset="0"/>
                 <a:ea typeface="Meiryo UI" pitchFamily="34" charset="-122"/>
@@ -5914,7 +6167,7 @@
       </p:sp>
       <p:sp>
         <p:nvSpPr>
-          <p:cNvPr id="17" name="Text 15"/>
+          <p:cNvPr id="18" name="Text 15"/>
           <p:cNvSpPr txBox="1"/>
           <p:nvPr/>
         </p:nvSpPr>
@@ -5956,7 +6209,7 @@
       </p:sp>
       <p:sp>
         <p:nvSpPr>
-          <p:cNvPr id="18" name="Shape 16"/>
+          <p:cNvPr id="19" name="Shape 16"/>
           <p:cNvSpPr/>
           <p:nvPr/>
         </p:nvSpPr>
@@ -5985,7 +6238,7 @@
       </p:sp>
       <p:sp>
         <p:nvSpPr>
-          <p:cNvPr id="19" name="Shape 17"/>
+          <p:cNvPr id="20" name="Shape 17"/>
           <p:cNvSpPr/>
           <p:nvPr/>
         </p:nvSpPr>
@@ -5998,14 +6251,14 @@
             <a:avLst/>
           </a:prstGeom>
           <a:solidFill>
-            <a:srgbClr val="1E2761"/>
+            <a:srgbClr val="045292"/>
           </a:solidFill>
           <a:ln/>
         </p:spPr>
       </p:sp>
       <p:sp>
         <p:nvSpPr>
-          <p:cNvPr id="20" name="Text 18"/>
+          <p:cNvPr id="21" name="Text 18"/>
           <p:cNvSpPr txBox="1"/>
           <p:nvPr/>
         </p:nvSpPr>
@@ -6044,7 +6297,7 @@
       </p:sp>
       <p:sp>
         <p:nvSpPr>
-          <p:cNvPr id="21" name="Text 19"/>
+          <p:cNvPr id="22" name="Text 19"/>
           <p:cNvSpPr txBox="1"/>
           <p:nvPr/>
         </p:nvSpPr>
@@ -6069,7 +6322,7 @@
             <a:r>
               <a:rPr lang="en-US" sz="1650" b="1" dirty="0">
                 <a:solidFill>
-                  <a:srgbClr val="1E2761"/>
+                  <a:srgbClr val="045292"/>
                 </a:solidFill>
                 <a:latin typeface="Meiryo UI" pitchFamily="34" charset="0"/>
                 <a:ea typeface="Meiryo UI" pitchFamily="34" charset="-122"/>
@@ -6083,7 +6336,7 @@
       </p:sp>
       <p:sp>
         <p:nvSpPr>
-          <p:cNvPr id="22" name="Text 20"/>
+          <p:cNvPr id="23" name="Text 20"/>
           <p:cNvSpPr txBox="1"/>
           <p:nvPr/>
         </p:nvSpPr>
@@ -6125,7 +6378,7 @@
       </p:sp>
       <p:sp>
         <p:nvSpPr>
-          <p:cNvPr id="23" name="Text 21"/>
+          <p:cNvPr id="24" name="Text 21"/>
           <p:cNvSpPr txBox="1"/>
           <p:nvPr/>
         </p:nvSpPr>
@@ -6194,9 +6447,33 @@
           <a:chExt cx="0" cy="0"/>
         </a:xfrm>
       </p:grpSpPr>
-      <p:sp>
-        <p:nvSpPr>
-          <p:cNvPr id="2" name="Text 0"/>
+      <p:pic>
+        <p:nvPicPr>
+          <p:cNvPr id="2" name="Image 0" descr="/tmp/claude-0/-home-user-takashima-yuto-site/d68be841-4a50-5410-afb9-fdf52bb655ee/scratchpad/sekisan/kcm_stripe.png">    </p:cNvPr>
+          <p:cNvPicPr>
+            <a:picLocks noChangeAspect="1"/>
+          </p:cNvPicPr>
+          <p:nvPr/>
+        </p:nvPicPr>
+        <p:blipFill>
+          <a:blip r:embed="rId1"/>
+          <a:stretch>
+            <a:fillRect/>
+          </a:stretch>
+        </p:blipFill>
+        <p:spPr>
+          <a:xfrm>
+            <a:off x="0" y="6656832"/>
+            <a:ext cx="12188952" cy="201168"/>
+          </a:xfrm>
+          <a:prstGeom prst="rect">
+            <a:avLst/>
+          </a:prstGeom>
+        </p:spPr>
+      </p:pic>
+      <p:sp>
+        <p:nvSpPr>
+          <p:cNvPr id="3" name="Text 0"/>
           <p:cNvSpPr txBox="1"/>
           <p:nvPr/>
         </p:nvSpPr>
@@ -6221,7 +6498,7 @@
             <a:r>
               <a:rPr lang="en-US" sz="2800" b="1" dirty="0">
                 <a:solidFill>
-                  <a:srgbClr val="1E2761"/>
+                  <a:srgbClr val="045292"/>
                 </a:solidFill>
                 <a:latin typeface="Meiryo UI" pitchFamily="34" charset="0"/>
                 <a:ea typeface="Meiryo UI" pitchFamily="34" charset="-122"/>
@@ -6235,7 +6512,7 @@
       </p:sp>
       <p:sp>
         <p:nvSpPr>
-          <p:cNvPr id="3" name="Text 1"/>
+          <p:cNvPr id="4" name="Text 1"/>
           <p:cNvSpPr txBox="1"/>
           <p:nvPr/>
         </p:nvSpPr>
@@ -6260,7 +6537,7 @@
             <a:r>
               <a:rPr lang="en-US" sz="1600" b="1" dirty="0">
                 <a:solidFill>
-                  <a:srgbClr val="1E2761"/>
+                  <a:srgbClr val="045292"/>
                 </a:solidFill>
                 <a:latin typeface="Meiryo UI" pitchFamily="34" charset="0"/>
                 <a:ea typeface="Meiryo UI" pitchFamily="34" charset="-122"/>
@@ -6274,7 +6551,7 @@
       </p:sp>
       <p:sp>
         <p:nvSpPr>
-          <p:cNvPr id="4" name="Text 2"/>
+          <p:cNvPr id="5" name="Text 2"/>
           <p:cNvSpPr txBox="1"/>
           <p:nvPr/>
         </p:nvSpPr>
@@ -6359,7 +6636,7 @@
       </p:sp>
       <p:sp>
         <p:nvSpPr>
-          <p:cNvPr id="5" name="Text 3"/>
+          <p:cNvPr id="6" name="Text 3"/>
           <p:cNvSpPr txBox="1"/>
           <p:nvPr/>
         </p:nvSpPr>
@@ -6384,7 +6661,7 @@
             <a:r>
               <a:rPr lang="en-US" sz="1600" b="1" dirty="0">
                 <a:solidFill>
-                  <a:srgbClr val="1E2761"/>
+                  <a:srgbClr val="045292"/>
                 </a:solidFill>
                 <a:latin typeface="Meiryo UI" pitchFamily="34" charset="0"/>
                 <a:ea typeface="Meiryo UI" pitchFamily="34" charset="-122"/>
@@ -6398,7 +6675,7 @@
       </p:sp>
       <p:sp>
         <p:nvSpPr>
-          <p:cNvPr id="6" name="Shape 4"/>
+          <p:cNvPr id="7" name="Shape 4"/>
           <p:cNvSpPr/>
           <p:nvPr/>
         </p:nvSpPr>
@@ -6413,14 +6690,14 @@
             </a:avLst>
           </a:prstGeom>
           <a:solidFill>
-            <a:srgbClr val="1E2761"/>
+            <a:srgbClr val="045292"/>
           </a:solidFill>
           <a:ln/>
         </p:spPr>
       </p:sp>
       <p:sp>
         <p:nvSpPr>
-          <p:cNvPr id="7" name="Text 5"/>
+          <p:cNvPr id="8" name="Text 5"/>
           <p:cNvSpPr txBox="1"/>
           <p:nvPr/>
         </p:nvSpPr>
@@ -6445,7 +6722,7 @@
             <a:r>
               <a:rPr lang="en-US" sz="1200" b="1" dirty="0">
                 <a:solidFill>
-                  <a:srgbClr val="CADCFC"/>
+                  <a:srgbClr val="D9E9F8"/>
                 </a:solidFill>
                 <a:latin typeface="Meiryo UI" pitchFamily="34" charset="0"/>
                 <a:ea typeface="Meiryo UI" pitchFamily="34" charset="-122"/>
@@ -6459,7 +6736,7 @@
       </p:sp>
       <p:sp>
         <p:nvSpPr>
-          <p:cNvPr id="8" name="Text 6"/>
+          <p:cNvPr id="9" name="Text 6"/>
           <p:cNvSpPr txBox="1"/>
           <p:nvPr/>
         </p:nvSpPr>
@@ -6498,7 +6775,7 @@
       </p:sp>
       <p:sp>
         <p:nvSpPr>
-          <p:cNvPr id="9" name="Text 7"/>
+          <p:cNvPr id="10" name="Text 7"/>
           <p:cNvSpPr txBox="1"/>
           <p:nvPr/>
         </p:nvSpPr>
@@ -6526,7 +6803,7 @@
             <a:r>
               <a:rPr lang="en-US" sz="1100" dirty="0">
                 <a:solidFill>
-                  <a:srgbClr val="CADCFC"/>
+                  <a:srgbClr val="D9E9F8"/>
                 </a:solidFill>
                 <a:latin typeface="Meiryo UI" pitchFamily="34" charset="0"/>
                 <a:ea typeface="Meiryo UI" pitchFamily="34" charset="-122"/>
@@ -6540,7 +6817,7 @@
       </p:sp>
       <p:sp>
         <p:nvSpPr>
-          <p:cNvPr id="10" name="Shape 8"/>
+          <p:cNvPr id="11" name="Shape 8"/>
           <p:cNvSpPr/>
           <p:nvPr/>
         </p:nvSpPr>
@@ -6562,7 +6839,7 @@
       </p:sp>
       <p:sp>
         <p:nvSpPr>
-          <p:cNvPr id="11" name="Text 9"/>
+          <p:cNvPr id="12" name="Text 9"/>
           <p:cNvSpPr txBox="1"/>
           <p:nvPr/>
         </p:nvSpPr>
@@ -6587,7 +6864,7 @@
             <a:r>
               <a:rPr lang="en-US" sz="1200" b="1" dirty="0">
                 <a:solidFill>
-                  <a:srgbClr val="0F6AB4"/>
+                  <a:srgbClr val="045292"/>
                 </a:solidFill>
                 <a:latin typeface="Meiryo UI" pitchFamily="34" charset="0"/>
                 <a:ea typeface="Meiryo UI" pitchFamily="34" charset="-122"/>
@@ -6601,7 +6878,7 @@
       </p:sp>
       <p:sp>
         <p:nvSpPr>
-          <p:cNvPr id="12" name="Text 10"/>
+          <p:cNvPr id="13" name="Text 10"/>
           <p:cNvSpPr txBox="1"/>
           <p:nvPr/>
         </p:nvSpPr>
@@ -6626,7 +6903,7 @@
             <a:r>
               <a:rPr lang="en-US" sz="1700" b="1" dirty="0">
                 <a:solidFill>
-                  <a:srgbClr val="1E2761"/>
+                  <a:srgbClr val="045292"/>
                 </a:solidFill>
                 <a:latin typeface="Meiryo UI" pitchFamily="34" charset="0"/>
                 <a:ea typeface="Meiryo UI" pitchFamily="34" charset="-122"/>
@@ -6640,7 +6917,7 @@
       </p:sp>
       <p:sp>
         <p:nvSpPr>
-          <p:cNvPr id="13" name="Text 11"/>
+          <p:cNvPr id="14" name="Text 11"/>
           <p:cNvSpPr txBox="1"/>
           <p:nvPr/>
         </p:nvSpPr>
@@ -6682,7 +6959,7 @@
       </p:sp>
       <p:sp>
         <p:nvSpPr>
-          <p:cNvPr id="14" name="Shape 12"/>
+          <p:cNvPr id="15" name="Shape 12"/>
           <p:cNvSpPr/>
           <p:nvPr/>
         </p:nvSpPr>
@@ -6704,7 +6981,7 @@
       </p:sp>
       <p:sp>
         <p:nvSpPr>
-          <p:cNvPr id="15" name="Text 13"/>
+          <p:cNvPr id="16" name="Text 13"/>
           <p:cNvSpPr txBox="1"/>
           <p:nvPr/>
         </p:nvSpPr>
@@ -6729,7 +7006,7 @@
             <a:r>
               <a:rPr lang="en-US" sz="1200" b="1" dirty="0">
                 <a:solidFill>
-                  <a:srgbClr val="0F6AB4"/>
+                  <a:srgbClr val="045292"/>
                 </a:solidFill>
                 <a:latin typeface="Meiryo UI" pitchFamily="34" charset="0"/>
                 <a:ea typeface="Meiryo UI" pitchFamily="34" charset="-122"/>
@@ -6743,7 +7020,7 @@
       </p:sp>
       <p:sp>
         <p:nvSpPr>
-          <p:cNvPr id="16" name="Text 14"/>
+          <p:cNvPr id="17" name="Text 14"/>
           <p:cNvSpPr txBox="1"/>
           <p:nvPr/>
         </p:nvSpPr>
@@ -6768,7 +7045,7 @@
             <a:r>
               <a:rPr lang="en-US" sz="1700" b="1" dirty="0">
                 <a:solidFill>
-                  <a:srgbClr val="1E2761"/>
+                  <a:srgbClr val="045292"/>
                 </a:solidFill>
                 <a:latin typeface="Meiryo UI" pitchFamily="34" charset="0"/>
                 <a:ea typeface="Meiryo UI" pitchFamily="34" charset="-122"/>
@@ -6782,7 +7059,7 @@
       </p:sp>
       <p:sp>
         <p:nvSpPr>
-          <p:cNvPr id="17" name="Text 15"/>
+          <p:cNvPr id="18" name="Text 15"/>
           <p:cNvSpPr txBox="1"/>
           <p:nvPr/>
         </p:nvSpPr>
@@ -6824,7 +7101,7 @@
       </p:sp>
       <p:sp>
         <p:nvSpPr>
-          <p:cNvPr id="18" name="Text 16"/>
+          <p:cNvPr id="19" name="Text 16"/>
           <p:cNvSpPr txBox="1"/>
           <p:nvPr/>
         </p:nvSpPr>
@@ -6863,7 +7140,7 @@
       </p:sp>
       <p:sp>
         <p:nvSpPr>
-          <p:cNvPr id="19" name="Text 17"/>
+          <p:cNvPr id="20" name="Text 17"/>
           <p:cNvSpPr txBox="1"/>
           <p:nvPr/>
         </p:nvSpPr>

</xml_diff>